<commit_message>
feat: create lesson plans, handouts, and presentation slides for English lessons 6 and 7
</commit_message>
<xml_diff>
--- a/Units/English/English_Unit_2/Lesson_Plans/Presentations/Lesson_06_Presentation.pptx
+++ b/Units/English/English_Unit_2/Lesson_Plans/Presentations/Lesson_06_Presentation.pptx
@@ -1693,7 +1693,7 @@
                 <a:ea typeface="Arial" pitchFamily="34" charset="-122"/>
                 <a:cs typeface="Arial" pitchFamily="34" charset="-120"/>
               </a:rPr>
-              <a:t> Tracy, Yasi, Larry, George.</a:t>
+              <a:t> Tracy, Mahina, Larry, Althea.</a:t>
             </a:r>
             <a:endParaRPr lang="en-US" sz="2000" dirty="0"/>
           </a:p>
@@ -3076,8 +3076,8 @@
         </p:nvSpPr>
         <p:spPr>
           <a:xfrm>
-            <a:off x="697035" y="1285875"/>
-            <a:ext cx="7749781" cy="426690"/>
+            <a:off x="475248" y="1285875"/>
+            <a:ext cx="8193354" cy="426690"/>
           </a:xfrm>
           <a:prstGeom prst="rect">
             <a:avLst/>
@@ -3104,7 +3104,7 @@
                 <a:ea typeface="Arial" pitchFamily="34" charset="-122"/>
                 <a:cs typeface="Arial" pitchFamily="34" charset="-120"/>
               </a:rPr>
-              <a:t>We've looked at the structures in the Cyclone Yasi page.</a:t>
+              <a:t>We've looked at the structures in the Cyclone Mahina page.</a:t>
             </a:r>
             <a:endParaRPr lang="en-US" sz="2400" dirty="0"/>
           </a:p>

</xml_diff>